<commit_message>
docs: update README, report, architecture, demo, slides and notebook for the GPU build
README rewritten (CPU and GPU setups, switches, VRAM table, test commands, CPU vs GPU
results, current limitations); FINAL_REPORT, architecture and demo script updated; progress
log Phase 7 and decision-log entries; LLM README; slides regenerated (spec's 10 titles) and
the walkthrough notebook re-executed. eval/results_gpu.md re-run on the final code: 20/20
answered with citations, 5/5 abstentions, p50 1.2 s. eval/results.md (CPU baseline) unchanged.

Co-Authored-By: Claude Opus 5.5 <noreply@anthropic.com>
</commit_message>
<xml_diff>
--- a/slides/we_assistant.pptx
+++ b/slides/we_assistant.pptx
@@ -3241,7 +3241,7 @@
               </a:defRPr>
             </a:pPr>
             <a:r>
-              <a:t>Build constraint: 2-day case-study PoC, laptop hardware, CPU only, no GPU</a:t>
+              <a:t>Build constraint: 2-day case-study PoC on CPU-only laptop hardware; later verified on an NVIDIA RTX 3080</a:t>
             </a:r>
           </a:p>
           <a:p>
@@ -3384,79 +3384,67 @@
               </a:defRPr>
             </a:pPr>
             <a:r>
-              <a:t>GPU serving (vLLM, larger Qwen) — compose.gpu.yaml already written, untested (no GPU on this laptop)</a:t>
-            </a:r>
-          </a:p>
-          <a:p>
-            <a:pPr>
-              <a:defRPr sz="1600">
-                <a:solidFill>
-                  <a:srgbClr val="241C2E"/>
-                </a:solidFill>
-              </a:defRPr>
-            </a:pPr>
-            <a:r>
-              <a:t>Chatterbox or a dedicated Egyptian Arabic TTS voice, once GPU-served</a:t>
-            </a:r>
-          </a:p>
-          <a:p>
-            <a:pPr>
-              <a:defRPr sz="1600">
-                <a:solidFill>
-                  <a:srgbClr val="241C2E"/>
-                </a:solidFill>
-              </a:defRPr>
-            </a:pPr>
-            <a:r>
-              <a:t>PaddleOCR or a VLM-based OCR path for better Arabic scanned-document accuracy</a:t>
-            </a:r>
-          </a:p>
-          <a:p>
-            <a:pPr>
-              <a:defRPr sz="1600">
-                <a:solidFill>
-                  <a:srgbClr val="241C2E"/>
-                </a:solidFill>
-              </a:defRPr>
-            </a:pPr>
-            <a:r>
-              <a:t>Postgres instead of SQLite for multi-instance scale</a:t>
-            </a:r>
-          </a:p>
-          <a:p>
-            <a:pPr>
-              <a:defRPr sz="1600">
-                <a:solidFill>
-                  <a:srgbClr val="241C2E"/>
-                </a:solidFill>
-              </a:defRPr>
-            </a:pPr>
-            <a:r>
-              <a:t>SSO / RBAC instead of the demo's session-id scoping</a:t>
-            </a:r>
-          </a:p>
-          <a:p>
-            <a:pPr>
-              <a:defRPr sz="1600">
-                <a:solidFill>
-                  <a:srgbClr val="241C2E"/>
-                </a:solidFill>
-              </a:defRPr>
-            </a:pPr>
-            <a:r>
-              <a:t>Queue workers for ingestion at scale (currently synchronous)</a:t>
-            </a:r>
-          </a:p>
-          <a:p>
-            <a:pPr>
-              <a:defRPr sz="1600">
-                <a:solidFill>
-                  <a:srgbClr val="241C2E"/>
-                </a:solidFill>
-              </a:defRPr>
-            </a:pPr>
-            <a:r>
-              <a:t>Production monitoring/observability</a:t>
+              <a:t>24 GB GPU (RTX 3090) and a larger model (Qwen3-8B) evaluated on the same question set; vLLM for many concurrent users</a:t>
+            </a:r>
+          </a:p>
+          <a:p>
+            <a:pPr>
+              <a:defRPr sz="1600">
+                <a:solidFill>
+                  <a:srgbClr val="241C2E"/>
+                </a:solidFill>
+              </a:defRPr>
+            </a:pPr>
+            <a:r>
+              <a:t>Chatterbox or a dedicated Egyptian Arabic TTS voice</a:t>
+            </a:r>
+          </a:p>
+          <a:p>
+            <a:pPr>
+              <a:defRPr sz="1600">
+                <a:solidFill>
+                  <a:srgbClr val="241C2E"/>
+                </a:solidFill>
+              </a:defRPr>
+            </a:pPr>
+            <a:r>
+              <a:t>PaddleOCR or a VLM-based OCR path for harder scanned documents</a:t>
+            </a:r>
+          </a:p>
+          <a:p>
+            <a:pPr>
+              <a:defRPr sz="1600">
+                <a:solidFill>
+                  <a:srgbClr val="241C2E"/>
+                </a:solidFill>
+              </a:defRPr>
+            </a:pPr>
+            <a:r>
+              <a:t>Postgres instead of SQLite; queue workers for ingestion at scale</a:t>
+            </a:r>
+          </a:p>
+          <a:p>
+            <a:pPr>
+              <a:defRPr sz="1600">
+                <a:solidFill>
+                  <a:srgbClr val="241C2E"/>
+                </a:solidFill>
+              </a:defRPr>
+            </a:pPr>
+            <a:r>
+              <a:t>SSO / RBAC instead of session-id scoping</a:t>
+            </a:r>
+          </a:p>
+          <a:p>
+            <a:pPr>
+              <a:defRPr sz="1600">
+                <a:solidFill>
+                  <a:srgbClr val="241C2E"/>
+                </a:solidFill>
+              </a:defRPr>
+            </a:pPr>
+            <a:r>
+              <a:t>Auto-restarting services, CUDA backend image, monitoring/observability</a:t>
             </a:r>
           </a:p>
           <a:p>
@@ -3623,31 +3611,31 @@
               </a:defRPr>
             </a:pPr>
             <a:r>
-              <a:t>backend (FastAPI) — orchestration, RAG, ingestion, OCR, embeddings, SQLite</a:t>
-            </a:r>
-          </a:p>
-          <a:p>
-            <a:pPr>
-              <a:defRPr sz="1600">
-                <a:solidFill>
-                  <a:srgbClr val="241C2E"/>
-                </a:solidFill>
-              </a:defRPr>
-            </a:pPr>
-            <a:r>
-              <a:t>llm (llama.cpp server) — Qwen3-4B Q4_K_M GGUF</a:t>
-            </a:r>
-          </a:p>
-          <a:p>
-            <a:pPr>
-              <a:defRPr sz="1600">
-                <a:solidFill>
-                  <a:srgbClr val="241C2E"/>
-                </a:solidFill>
-              </a:defRPr>
-            </a:pPr>
-            <a:r>
-              <a:t>asr (faster-whisper) — large-v3-turbo, int8, CPU</a:t>
+              <a:t>backend (FastAPI) — guardrails, routing, RAG, ingestion, OCR, embeddings + reranker, SQLite</a:t>
+            </a:r>
+          </a:p>
+          <a:p>
+            <a:pPr>
+              <a:defRPr sz="1600">
+                <a:solidFill>
+                  <a:srgbClr val="241C2E"/>
+                </a:solidFill>
+              </a:defRPr>
+            </a:pPr>
+            <a:r>
+              <a:t>llm (llama.cpp server) — Qwen3-4B Q4_K_M GGUF, 4 parallel slots x 4096 tokens</a:t>
+            </a:r>
+          </a:p>
+          <a:p>
+            <a:pPr>
+              <a:defRPr sz="1600">
+                <a:solidFill>
+                  <a:srgbClr val="241C2E"/>
+                </a:solidFill>
+              </a:defRPr>
+            </a:pPr>
+            <a:r>
+              <a:t>asr (faster-whisper) — large-v3-turbo (int8 on CPU, fp16 on GPU)</a:t>
             </a:r>
           </a:p>
           <a:p>
@@ -3683,7 +3671,7 @@
               </a:defRPr>
             </a:pPr>
             <a:r>
-              <a:t>All inter-service traffic on an internal-only Docker network</a:t>
+              <a:t>All inter-service traffic on an internal-only network</a:t>
             </a:r>
           </a:p>
           <a:p>
@@ -3695,7 +3683,7 @@
               </a:defRPr>
             </a:pPr>
             <a:r>
-              <a:t>On this build laptop: no Docker daemon available — verified instead as native host processes on the same ports (docs/decisions.md); every Dockerfile/compose file is real and spec-complete</a:t>
+              <a:t>Verified as native host processes on the same ports (no Docker daemon on either test machine); compose files config-validated</a:t>
             </a:r>
           </a:p>
         </p:txBody>
@@ -3826,67 +3814,67 @@
               </a:defRPr>
             </a:pPr>
             <a:r>
-              <a:t>te.eg crawled for real: 106 pages (95 Arabic, 11 English), robots.txt-respecting, 1 req/s</a:t>
-            </a:r>
-          </a:p>
-          <a:p>
-            <a:pPr lvl="1">
-              <a:defRPr sz="1400">
-                <a:solidFill>
-                  <a:srgbClr val="241C2E"/>
-                </a:solidFill>
-              </a:defRPr>
-            </a:pPr>
-            <a:r>
-              <a:t>Found &amp; fixed: a shared cookie jar let te.eg's language cookie leak across requests, flipping Arabic pages to English — fixed with isolated sessions per language track</a:t>
-            </a:r>
-          </a:p>
-          <a:p>
-            <a:pPr>
-              <a:defRPr sz="1600">
-                <a:solidFill>
-                  <a:srgbClr val="241C2E"/>
-                </a:solidFill>
-              </a:defRPr>
-            </a:pPr>
-            <a:r>
-              <a:t>PDF: per-page extraction (PyMuPDF) → NFKC normalize → garbled-Arabic detection → 300 DPI render + Tesseract OCR fallback</a:t>
-            </a:r>
-          </a:p>
-          <a:p>
-            <a:pPr lvl="1">
-              <a:defRPr sz="1400">
-                <a:solidFill>
-                  <a:srgbClr val="241C2E"/>
-                </a:solidFill>
-              </a:defRPr>
-            </a:pPr>
-            <a:r>
-              <a:t>Verified end-to-end on real fixtures: a clean text-layer PDF, a scanned (image-only) English PDF, and an image-only Arabic PDF — all three ingested and became answerable</a:t>
-            </a:r>
-          </a:p>
-          <a:p>
-            <a:pPr>
-              <a:defRPr sz="1600">
-                <a:solidFill>
-                  <a:srgbClr val="241C2E"/>
-                </a:solidFill>
-              </a:defRPr>
-            </a:pPr>
-            <a:r>
-              <a:t>DOCX (incl. tables), TXT (UTF-8 + cp1256 fallback), HTML, and images (direct OCR) also implemented and tested</a:t>
-            </a:r>
-          </a:p>
-          <a:p>
-            <a:pPr>
-              <a:defRPr sz="1600">
-                <a:solidFill>
-                  <a:srgbClr val="241C2E"/>
-                </a:solidFill>
-              </a:defRPr>
-            </a:pPr>
-            <a:r>
-              <a:t>322 chunks embedded (BAAI/bge-m3) and indexed into Qdrant from the te.eg crawl alone</a:t>
+              <a:t>te.eg crawled: 106 pages (95 Arabic, 11 English), robots.txt-respecting, 1 req/s; isolated sessions per language (a shared cookie jar flipped Arabic pages to English)</a:t>
+            </a:r>
+          </a:p>
+          <a:p>
+            <a:pPr>
+              <a:defRPr sz="1600">
+                <a:solidFill>
+                  <a:srgbClr val="241C2E"/>
+                </a:solidFill>
+              </a:defRPr>
+            </a:pPr>
+            <a:r>
+              <a:t>PDF: PyMuPDF per page → garbled-Arabic detection → 300 DPI render + Tesseract ara+eng OCR fallback</a:t>
+            </a:r>
+          </a:p>
+          <a:p>
+            <a:pPr>
+              <a:defRPr sz="1600">
+                <a:solidFill>
+                  <a:srgbClr val="241C2E"/>
+                </a:solidFill>
+              </a:defRPr>
+            </a:pPr>
+            <a:r>
+              <a:t>Scanned Arabic and English PDFs, DOCX tables, TXT (cp1256 fallback), HTML, images — all answerable (heavy test)</a:t>
+            </a:r>
+          </a:p>
+          <a:p>
+            <a:pPr>
+              <a:defRPr sz="1600">
+                <a:solidFill>
+                  <a:srgbClr val="241C2E"/>
+                </a:solidFill>
+              </a:defRPr>
+            </a:pPr>
+            <a:r>
+              <a:t>Price tables with merged header cells (colspan/rowspan) expanded into per-column headers — fixed 'col3: 775' garbage</a:t>
+            </a:r>
+          </a:p>
+          <a:p>
+            <a:pPr>
+              <a:defRPr sz="1600">
+                <a:solidFill>
+                  <a:srgbClr val="241C2E"/>
+                </a:solidFill>
+              </a:defRPr>
+            </a:pPr>
+            <a:r>
+              <a:t>Chunking: ~450 tokens, FAQ pairs and tables kept whole when they fit, oversized ones split on rows/sentences — 360 chunks, max 509 tokens</a:t>
+            </a:r>
+          </a:p>
+          <a:p>
+            <a:pPr>
+              <a:defRPr sz="1600">
+                <a:solidFill>
+                  <a:srgbClr val="241C2E"/>
+                </a:solidFill>
+              </a:defRPr>
+            </a:pPr>
+            <a:r>
+              <a:t>Uploads: injection sentences stripped, originals saved as data/uploads/&lt;uuid&gt;, private to the uploading session</a:t>
             </a:r>
           </a:p>
         </p:txBody>
@@ -4017,7 +4005,7 @@
               </a:defRPr>
             </a:pPr>
             <a:r>
-              <a:t>Dense (bge-m3) + sparse (lexical weights), fused with Reciprocal Rank Fusion (RRF)</a:t>
+              <a:t>Dense (bge-m3) + sparse (lexical weights), fused with Reciprocal Rank Fusion, reranked by bge-reranker-v2-m3</a:t>
             </a:r>
           </a:p>
           <a:p>
@@ -4041,7 +4029,7 @@
               </a:defRPr>
             </a:pPr>
             <a:r>
-              <a:t>Dense only:        Recall@4 = 0.95,  MRR = 0.825</a:t>
+              <a:t>Dense only:        Recall@4 = 0.95,  MRR = 0.85</a:t>
             </a:r>
           </a:p>
           <a:p>
@@ -4053,7 +4041,7 @@
               </a:defRPr>
             </a:pPr>
             <a:r>
-              <a:t>Hybrid (RRF):      Recall@4 = 0.95,  MRR = 0.662</a:t>
+              <a:t>Hybrid (RRF):      Recall@4 = 0.95,  MRR = 0.642</a:t>
             </a:r>
           </a:p>
           <a:p>
@@ -4077,19 +4065,19 @@
               </a:defRPr>
             </a:pPr>
             <a:r>
-              <a:t>Finding: RRF fusion alone can push the best result down in rank versus dense-only; reranking (bge-reranker-v2-m3) recovers full ranking quality</a:t>
-            </a:r>
-          </a:p>
-          <a:p>
-            <a:pPr>
-              <a:defRPr sz="1600">
-                <a:solidFill>
-                  <a:srgbClr val="241C2E"/>
-                </a:solidFill>
-              </a:defRPr>
-            </a:pPr>
-            <a:r>
-              <a:t>Reranker is CPU-expensive per call — kept default-off per spec, enabled selectively where ranking precision matters more than latency</a:t>
+              <a:t>RRF alone pushes the best passage down; reranking recovers it — and its 0-1 score is the evidence gate</a:t>
+            </a:r>
+          </a:p>
+          <a:p>
+            <a:pPr>
+              <a:defRPr sz="1600">
+                <a:solidFill>
+                  <a:srgbClr val="241C2E"/>
+                </a:solidFill>
+              </a:defRPr>
+            </a:pPr>
+            <a:r>
+              <a:t>RRF scores are rank-based (rank 1 ≈ 1/61), so the old RRF threshold rejected almost nothing; the reranker gate (0.02) separates off-topic (~0.001) from answerable (≥ 0.25)</a:t>
             </a:r>
           </a:p>
         </p:txBody>
@@ -4142,7 +4130,7 @@
               </a:defRPr>
             </a:pPr>
             <a:r>
-              <a:t>Grounding and Citations</a:t>
+              <a:t>Grounding, Citations and Guardrails</a:t>
             </a:r>
           </a:p>
         </p:txBody>
@@ -4220,67 +4208,67 @@
               </a:defRPr>
             </a:pPr>
             <a:r>
-              <a:t>Every fact must cite a numbered source [S#]; sources are data to read, never instructions to follow</a:t>
-            </a:r>
-          </a:p>
-          <a:p>
-            <a:pPr>
-              <a:defRPr sz="1600">
-                <a:solidFill>
-                  <a:srgbClr val="241C2E"/>
-                </a:solidFill>
-              </a:defRPr>
-            </a:pPr>
-            <a:r>
-              <a:t>Post-generation validator: drops unknown [S#] labels, flags numbers absent from any cited source</a:t>
-            </a:r>
-          </a:p>
-          <a:p>
-            <a:pPr>
-              <a:defRPr sz="1600">
-                <a:solidFill>
-                  <a:srgbClr val="241C2E"/>
-                </a:solidFill>
-              </a:defRPr>
-            </a:pPr>
-            <a:r>
-              <a:t>Arabic-Indic digit normalization (found via testing — ١١١ vs 111 was a false-positive source)</a:t>
-            </a:r>
-          </a:p>
-          <a:p>
-            <a:pPr>
-              <a:defRPr sz="1600">
-                <a:solidFill>
-                  <a:srgbClr val="241C2E"/>
-                </a:solidFill>
-              </a:defRPr>
-            </a:pPr>
-            <a:r>
-              <a:t>A factual answer with zero valid citations is downgraded to insufficient_evidence</a:t>
-            </a:r>
-          </a:p>
-          <a:p>
-            <a:pPr>
-              <a:defRPr sz="1600">
-                <a:solidFill>
-                  <a:srgbClr val="241C2E"/>
-                </a:solidFill>
-              </a:defRPr>
-            </a:pPr>
-            <a:r>
-              <a:t>Caught a real model hallucination in testing: the LLM stated a support phone number not present in its cited source — the validator flagged it correctly</a:t>
-            </a:r>
-          </a:p>
-          <a:p>
-            <a:pPr>
-              <a:defRPr sz="1600">
-                <a:solidFill>
-                  <a:srgbClr val="241C2E"/>
-                </a:solidFill>
-              </a:defRPr>
-            </a:pPr>
-            <a:r>
-              <a:t>Retrieval-score gate returns insufficient_evidence before even calling the LLM when evidence is weak</a:t>
+              <a:t>Every fact cites a numbered source; sources are tagged official (te.eg) or uploaded, and are data, never instructions</a:t>
+            </a:r>
+          </a:p>
+          <a:p>
+            <a:pPr>
+              <a:defRPr sz="1600">
+                <a:solidFill>
+                  <a:srgbClr val="241C2E"/>
+                </a:solidFill>
+              </a:defRPr>
+            </a:pPr>
+            <a:r>
+              <a:t>Validator drops unknown [S#] labels and flags numbers absent from the cited sources (list numbering and Arabic-Indic digits handled)</a:t>
+            </a:r>
+          </a:p>
+          <a:p>
+            <a:pPr>
+              <a:defRPr sz="1600">
+                <a:solidFill>
+                  <a:srgbClr val="241C2E"/>
+                </a:solidFill>
+              </a:defRPr>
+            </a:pPr>
+            <a:r>
+              <a:t>Guardrails: small-talk shortcut → regex injection pre-filter → LLM router (off_topic / injection / question + clean standalone query) → reranker evidence gate</a:t>
+            </a:r>
+          </a:p>
+          <a:p>
+            <a:pPr>
+              <a:defRPr sz="1600">
+                <a:solidFill>
+                  <a:srgbClr val="241C2E"/>
+                </a:solidFill>
+              </a:defRPr>
+            </a:pPr>
+            <a:r>
+              <a:t>Answer prompt gets only the standalone query (passing chat history made the 4B model answer one turn late)</a:t>
+            </a:r>
+          </a:p>
+          <a:p>
+            <a:pPr>
+              <a:defRPr sz="1600">
+                <a:solidFill>
+                  <a:srgbClr val="241C2E"/>
+                </a:solidFill>
+              </a:defRPr>
+            </a:pPr>
+            <a:r>
+              <a:t>Output checks: wrong language/script → one regeneration; system-prompt leak → withheld</a:t>
+            </a:r>
+          </a:p>
+          <a:p>
+            <a:pPr>
+              <a:defRPr sz="1600">
+                <a:solidFill>
+                  <a:srgbClr val="241C2E"/>
+                </a:solidFill>
+              </a:defRPr>
+            </a:pPr>
+            <a:r>
+              <a:t>Heavy test: 10/10 off-topic and 7/7 injection refused, 10/10 tricky legitimate questions answered; te.eg preferred over a conflicting upload, with both stated</a:t>
             </a:r>
           </a:p>
         </p:txBody>
@@ -4333,7 +4321,7 @@
               </a:defRPr>
             </a:pPr>
             <a:r>
-              <a:t>Speech: ASR and TTS</a:t>
+              <a:t>Speech: ASR Comparison and TTS</a:t>
             </a:r>
           </a:p>
         </p:txBody>
@@ -4411,67 +4399,67 @@
               </a:defRPr>
             </a:pPr>
             <a:r>
-              <a:t>ASR: faster-whisper large-v3-turbo (default) vs large-v3, both downloaded for comparison</a:t>
-            </a:r>
-          </a:p>
-          <a:p>
-            <a:pPr>
-              <a:defRPr sz="1600">
-                <a:solidFill>
-                  <a:srgbClr val="241C2E"/>
-                </a:solidFill>
-              </a:defRPr>
-            </a:pPr>
-            <a:r>
-              <a:t>Real /transcribe tests: clean English, Egyptian Arabic, and noise-injected English clips all transcribed correctly; silence correctly rejected (no_speech_detected)</a:t>
-            </a:r>
-          </a:p>
-          <a:p>
-            <a:pPr>
-              <a:defRPr sz="1600">
-                <a:solidFill>
-                  <a:srgbClr val="241C2E"/>
-                </a:solidFill>
-              </a:defRPr>
-            </a:pPr>
-            <a:r>
-              <a:t>TTS: Piper, English (en_US-lessac-medium) + Arabic (ar_JO-kareem-medium) voices</a:t>
-            </a:r>
-          </a:p>
-          <a:p>
-            <a:pPr>
-              <a:defRPr sz="1600">
-                <a:solidFill>
-                  <a:srgbClr val="241C2E"/>
-                </a:solidFill>
-              </a:defRPr>
-            </a:pPr>
-            <a:r>
-              <a:t>speech_text.py strips citations/markdown/URLs, verbalizes numbers (num2words), respells English brand names for the Arabic voice</a:t>
-            </a:r>
-          </a:p>
-          <a:p>
-            <a:pPr>
-              <a:defRPr sz="1600">
-                <a:solidFill>
-                  <a:srgbClr val="241C2E"/>
-                </a:solidFill>
-              </a:defRPr>
-            </a:pPr>
-            <a:r>
-              <a:t>Limitation, stated honestly: Piper's Arabic voice is noticeably more robotic than English — Chatterbox (GPU-only) is the production-roadmap upgrade</a:t>
-            </a:r>
-          </a:p>
-          <a:p>
-            <a:pPr>
-              <a:defRPr sz="1600">
-                <a:solidFill>
-                  <a:srgbClr val="241C2E"/>
-                </a:solidFill>
-              </a:defRPr>
-            </a:pPr>
-            <a:r>
-              <a:t>Full WER/CER ablation (beam 1 vs 5, with/without hotwords) pending real recorded clips from Ahmed — synthetic clips used for plumbing only</a:t>
+              <a:t>ASR: faster-whisper large-v3-turbo (deployed) vs large-v3, beam 1/5, telecom hotwords on/off — eval/asr_eval.py</a:t>
+            </a:r>
+          </a:p>
+          <a:p>
+            <a:pPr>
+              <a:defRPr sz="1600">
+                <a:solidFill>
+                  <a:srgbClr val="241C2E"/>
+                </a:solidFill>
+              </a:defRPr>
+            </a:pPr>
+            <a:r>
+              <a:t>Synthetic TTS clips (plumbing check): deployed setting lowest WER (13.1%) and fastest; EN and MSA exact; large-v3 not better</a:t>
+            </a:r>
+          </a:p>
+          <a:p>
+            <a:pPr>
+              <a:defRPr sz="1600">
+                <a:solidFill>
+                  <a:srgbClr val="241C2E"/>
+                </a:solidFill>
+              </a:defRPr>
+            </a:pPr>
+            <a:r>
+              <a:t>Hotword-echo guard: Whisper sometimes returned its own hotword prompt on clipped audio — detected and re-transcribed</a:t>
+            </a:r>
+          </a:p>
+          <a:p>
+            <a:pPr>
+              <a:defRPr sz="1600">
+                <a:solidFill>
+                  <a:srgbClr val="241C2E"/>
+                </a:solidFill>
+              </a:defRPr>
+            </a:pPr>
+            <a:r>
+              <a:t>TTS: Piper, English (en_US-lessac-medium) + Arabic (ar_JO-kareem-medium); speech_text.py strips citations, verbalizes numbers, respells brand names</a:t>
+            </a:r>
+          </a:p>
+          <a:p>
+            <a:pPr>
+              <a:defRPr sz="1600">
+                <a:solidFill>
+                  <a:srgbClr val="241C2E"/>
+                </a:solidFill>
+              </a:defRPr>
+            </a:pPr>
+            <a:r>
+              <a:t>Real recorded clips (Egyptian dialect, noise, code-switching) still to be collected — eval/RECORDING_CHECKLIST.md</a:t>
+            </a:r>
+          </a:p>
+          <a:p>
+            <a:pPr>
+              <a:defRPr sz="1600">
+                <a:solidFill>
+                  <a:srgbClr val="241C2E"/>
+                </a:solidFill>
+              </a:defRPr>
+            </a:pPr>
+            <a:r>
+              <a:t>Limitation: Piper's Arabic voice is more robotic than English — a better Arabic/Egyptian voice is on the roadmap</a:t>
             </a:r>
           </a:p>
         </p:txBody>
@@ -4602,43 +4590,43 @@
               </a:defRPr>
             </a:pPr>
             <a:r>
-              <a:t>HF_HUB_OFFLINE=1 / TRANSFORMERS_OFFLINE=1 everywhere; models load from local disk only at runtime</a:t>
-            </a:r>
-          </a:p>
-          <a:p>
-            <a:pPr>
-              <a:defRPr sz="1600">
-                <a:solidFill>
-                  <a:srgbClr val="241C2E"/>
-                </a:solidFill>
-              </a:defRPr>
-            </a:pPr>
-            <a:r>
-              <a:t>Every inference call (LLM/ASR/TTS/Qdrant/embeddings) observed going to 127.0.0.1 only</a:t>
-            </a:r>
-          </a:p>
-          <a:p>
-            <a:pPr>
-              <a:defRPr sz="1600">
-                <a:solidFill>
-                  <a:srgbClr val="241C2E"/>
-                </a:solidFill>
-              </a:defRPr>
-            </a:pPr>
-            <a:r>
-              <a:t>Qwen3-4B chosen over larger models specifically to keep CPU latency bounded on laptop hardware</a:t>
-            </a:r>
-          </a:p>
-          <a:p>
-            <a:pPr>
-              <a:defRPr sz="1600">
-                <a:solidFill>
-                  <a:srgbClr val="241C2E"/>
-                </a:solidFill>
-              </a:defRPr>
-            </a:pPr>
-            <a:r>
-              <a:t>int8 ASR, CPU-tuned thread counts (physical cores), reranker default-off — every choice tuned for CPU</a:t>
+              <a:t>HF_HUB_OFFLINE=1 / TRANSFORMERS_OFFLINE=1 everywhere; models load from local disk only; every call goes to 127.0.0.1</a:t>
+            </a:r>
+          </a:p>
+          <a:p>
+            <a:pPr>
+              <a:defRPr sz="1600">
+                <a:solidFill>
+                  <a:srgbClr val="241C2E"/>
+                </a:solidFill>
+              </a:defRPr>
+            </a:pPr>
+            <a:r>
+              <a:t>Qwen3-4B Q4 chosen to keep CPU latency bounded; the same models run unchanged on a GPU</a:t>
+            </a:r>
+          </a:p>
+          <a:p>
+            <a:pPr>
+              <a:defRPr sz="1600">
+                <a:solidFill>
+                  <a:srgbClr val="241C2E"/>
+                </a:solidFill>
+              </a:defRPr>
+            </a:pPr>
+            <a:r>
+              <a:t>CPU laptop: ~66 s p50 per answer.  RTX 3080: 1.2 s p50 — LLM, ASR, embedder and reranker on the GPU</a:t>
+            </a:r>
+          </a:p>
+          <a:p>
+            <a:pPr>
+              <a:defRPr sz="1600">
+                <a:solidFill>
+                  <a:srgbClr val="241C2E"/>
+                </a:solidFill>
+              </a:defRPr>
+            </a:pPr>
+            <a:r>
+              <a:t>GPU memory (measured): LLM 3.96 GB, ASR 2.5 GB, embedder 1.9 GB, reranker +0.9 GB → 9.2 GB for the app; 24 GB cards run eval alongside</a:t>
             </a:r>
           </a:p>
           <a:p>
@@ -4781,67 +4769,67 @@
               </a:defRPr>
             </a:pPr>
             <a:r>
-              <a:t>25 real questions (10 EN, 10 AR mixing MSA/Egyptian, 5 unanswerable) — facts copied from crawled text, not generated</a:t>
-            </a:r>
-          </a:p>
-          <a:p>
-            <a:pPr>
-              <a:defRPr sz="1600">
-                <a:solidFill>
-                  <a:srgbClr val="241C2E"/>
-                </a:solidFill>
-              </a:defRPr>
-            </a:pPr>
-            <a:r>
-              <a:t>Retrieval: Recall@4 = 0.95 across dense/hybrid/hybrid+rerank (see slide 4 for the MRR ablation)</a:t>
-            </a:r>
-          </a:p>
-          <a:p>
-            <a:pPr>
-              <a:defRPr sz="1600">
-                <a:solidFill>
-                  <a:srgbClr val="241C2E"/>
-                </a:solidFill>
-              </a:defRPr>
-            </a:pPr>
-            <a:r>
-              <a:t>Real /chat answers verified for EN, Egyptian dialect, and MSA questions — all correctly cited</a:t>
-            </a:r>
-          </a:p>
-          <a:p>
-            <a:pPr>
-              <a:defRPr sz="1600">
-                <a:solidFill>
-                  <a:srgbClr val="241C2E"/>
-                </a:solidFill>
-              </a:defRPr>
-            </a:pPr>
-            <a:r>
-              <a:t>Off-topic question correctly abstains (insufficient_evidence), verified live</a:t>
-            </a:r>
-          </a:p>
-          <a:p>
-            <a:pPr>
-              <a:defRPr sz="1600">
-                <a:solidFill>
-                  <a:srgbClr val="241C2E"/>
-                </a:solidFill>
-              </a:defRPr>
-            </a:pPr>
-            <a:r>
-              <a:t>LLM latency is the dominant cost: ~80-140s per answer on this CPU (4B model, ~2k-token context, 8 threads) — see eval/results.md for the full pipeline run's p50/p95</a:t>
-            </a:r>
-          </a:p>
-          <a:p>
-            <a:pPr>
-              <a:defRPr sz="1600">
-                <a:solidFill>
-                  <a:srgbClr val="241C2E"/>
-                </a:solidFill>
-              </a:defRPr>
-            </a:pPr>
-            <a:r>
-              <a:t>Local vs OpenRouter comparison: not run this session (no working API key provided — see docs/decisions.md)</a:t>
+              <a:t>25 real questions (10 EN, 10 AR mixing MSA/Egyptian, 5 unanswerable) — facts copied from crawled text</a:t>
+            </a:r>
+          </a:p>
+          <a:p>
+            <a:pPr>
+              <a:defRPr sz="1600">
+                <a:solidFill>
+                  <a:srgbClr val="241C2E"/>
+                </a:solidFill>
+              </a:defRPr>
+            </a:pPr>
+            <a:r>
+              <a:t>CPU baseline: 19/20 answered with citations, 2/5 unanswerable refused, p50 66.5 s / p95 100.7 s</a:t>
+            </a:r>
+          </a:p>
+          <a:p>
+            <a:pPr>
+              <a:defRPr sz="1600">
+                <a:solidFill>
+                  <a:srgbClr val="241C2E"/>
+                </a:solidFill>
+              </a:defRPr>
+            </a:pPr>
+            <a:r>
+              <a:t>GPU + guardrails: 20/20 answered with citations, 5/5 refused, p50 1.2 s / p95 1.9 s</a:t>
+            </a:r>
+          </a:p>
+          <a:p>
+            <a:pPr>
+              <a:defRPr sz="1600">
+                <a:solidFill>
+                  <a:srgbClr val="241C2E"/>
+                </a:solidFill>
+              </a:defRPr>
+            </a:pPr>
+            <a:r>
+              <a:t>8 simultaneous users: 32/32 answered, p50 5.8 s (after sizing llama-server's KV pool per slot)</a:t>
+            </a:r>
+          </a:p>
+          <a:p>
+            <a:pPr>
+              <a:defRPr sz="1600">
+                <a:solidFill>
+                  <a:srgbClr val="241C2E"/>
+                </a:solidFill>
+              </a:defRPr>
+            </a:pPr>
+            <a:r>
+              <a:t>Heavy system test 49/49, 101 unit + 6 live tests, GPU soak test without memory growth</a:t>
+            </a:r>
+          </a:p>
+          <a:p>
+            <a:pPr>
+              <a:defRPr sz="1600">
+                <a:solidFill>
+                  <a:srgbClr val="241C2E"/>
+                </a:solidFill>
+              </a:defRPr>
+            </a:pPr>
+            <a:r>
+              <a:t>Local vs OpenRouter comparison: not run — the provided API key was rejected (401)</a:t>
             </a:r>
           </a:p>
         </p:txBody>
@@ -4972,79 +4960,67 @@
               </a:defRPr>
             </a:pPr>
             <a:r>
-              <a:t>No Docker daemon on the build laptop — container paths real but untested here; native fallback used for all verification</a:t>
-            </a:r>
-          </a:p>
-          <a:p>
-            <a:pPr>
-              <a:defRPr sz="1600">
-                <a:solidFill>
-                  <a:srgbClr val="241C2E"/>
-                </a:solidFill>
-              </a:defRPr>
-            </a:pPr>
-            <a:r>
-              <a:t>LLM answer latency (60-140s) is high for a live demo — inherent to CPU-only 4B-model serving with a full RAG context</a:t>
-            </a:r>
-          </a:p>
-          <a:p>
-            <a:pPr>
-              <a:defRPr sz="1600">
-                <a:solidFill>
-                  <a:srgbClr val="241C2E"/>
-                </a:solidFill>
-              </a:defRPr>
-            </a:pPr>
-            <a:r>
-              <a:t>No real recorded audio clips yet — WER/CER numbers pending Ahmed's recordings</a:t>
-            </a:r>
-          </a:p>
-          <a:p>
-            <a:pPr>
-              <a:defRPr sz="1600">
-                <a:solidFill>
-                  <a:srgbClr val="241C2E"/>
-                </a:solidFill>
-              </a:defRPr>
-            </a:pPr>
-            <a:r>
-              <a:t>OpenRouter comparison unavailable — no working API key this session</a:t>
-            </a:r>
-          </a:p>
-          <a:p>
-            <a:pPr>
-              <a:defRPr sz="1600">
-                <a:solidFill>
-                  <a:srgbClr val="241C2E"/>
-                </a:solidFill>
-              </a:defRPr>
-            </a:pPr>
-            <a:r>
-              <a:t>Arabic OCR accuracy imperfect on synthetic (non-photographic) renders — numbers and word content recovered correctly, letter-level reordering observed</a:t>
-            </a:r>
-          </a:p>
-          <a:p>
-            <a:pPr>
-              <a:defRPr sz="1600">
-                <a:solidFill>
-                  <a:srgbClr val="241C2E"/>
-                </a:solidFill>
-              </a:defRPr>
-            </a:pPr>
-            <a:r>
-              <a:t>Piper's Arabic voice quality is noticeably behind its English voice</a:t>
-            </a:r>
-          </a:p>
-          <a:p>
-            <a:pPr>
-              <a:defRPr sz="1600">
-                <a:solidFill>
-                  <a:srgbClr val="241C2E"/>
-                </a:solidFill>
-              </a:defRPr>
-            </a:pPr>
-            <a:r>
-              <a:t>Headless-browser automated E2E testing of long-LLM-wait flows is unreliable in this specific sandbox (thoroughly diagnosed, documented as an automation-environment limitation, not an app defect)</a:t>
+              <a:t>Containers never run (no Docker daemon on either machine) — native processes used; Docker backend image uses CPU torch</a:t>
+            </a:r>
+          </a:p>
+          <a:p>
+            <a:pPr>
+              <a:defRPr sz="1600">
+                <a:solidFill>
+                  <a:srgbClr val="241C2E"/>
+                </a:solidFill>
+              </a:defRPr>
+            </a:pPr>
+            <a:r>
+              <a:t>No real recorded audio yet — ASR accuracy measured on synthetic TTS speech only</a:t>
+            </a:r>
+          </a:p>
+          <a:p>
+            <a:pPr>
+              <a:defRPr sz="1600">
+                <a:solidFill>
+                  <a:srgbClr val="241C2E"/>
+                </a:solidFill>
+              </a:defRPr>
+            </a:pPr>
+            <a:r>
+              <a:t>CPU latency ~1-2 min per answer; the router's extra LLM call on CPU not re-measured</a:t>
+            </a:r>
+          </a:p>
+          <a:p>
+            <a:pPr>
+              <a:defRPr sz="1600">
+                <a:solidFill>
+                  <a:srgbClr val="241C2E"/>
+                </a:solidFill>
+              </a:defRPr>
+            </a:pPr>
+            <a:r>
+              <a:t>10 GB GPUs are tight: re-indexing or eval needs the backend stopped</a:t>
+            </a:r>
+          </a:p>
+          <a:p>
+            <a:pPr>
+              <a:defRPr sz="1600">
+                <a:solidFill>
+                  <a:srgbClr val="241C2E"/>
+                </a:solidFill>
+              </a:defRPr>
+            </a:pPr>
+            <a:r>
+              <a:t>A conflicting upload is only flagged when the official passage is also retrieved</a:t>
+            </a:r>
+          </a:p>
+          <a:p>
+            <a:pPr>
+              <a:defRPr sz="1600">
+                <a:solidFill>
+                  <a:srgbClr val="241C2E"/>
+                </a:solidFill>
+              </a:defRPr>
+            </a:pPr>
+            <a:r>
+              <a:t>4B-model quirks (own unit conversions, language drift) need the validator and reminders; Piper's Arabic voice lags English</a:t>
             </a:r>
           </a:p>
         </p:txBody>

</xml_diff>